<commit_message>
Praktikum 2: Header, Card, CustomButton, Counter + doc & README update
- Tambah Header, CustomButton di components/praktikum/
- Halaman Praktikum: Target Pelajaran (Header, Card, CustomButton, Counter) + Contoh Lain
- Hapus duplikat Counter di halaman Praktikum
- Ikon tab Praktikum: graduationcap.fill (school)
- Komentar lengkap di Header, CustomButton, dan file terkait
- Update doc PRAKTIKUM_02 dan README dengan struktur terbaru

Made-with: Cursor
</commit_message>
<xml_diff>
--- a/doc/Slide_Pertemuan_2_Pemrograman_Mobile_II.pptx
+++ b/doc/Slide_Pertemuan_2_Pemrograman_Mobile_II.pptx
@@ -8909,7 +8909,12 @@
           <a:lstStyle/>
           <a:p>
             <a:r>
-              <a:t>Apa itu Functional Component?</a:t>
+              <a:rPr dirty="0" err="1"/>
+              <a:t>Apa</a:t>
+            </a:r>
+            <a:r>
+              <a:rPr dirty="0"/>
+              <a:t> itu Functional Component?</a:t>
             </a:r>
           </a:p>
         </p:txBody>

</xml_diff>